<commit_message>
Livro LLM: slides dos capítulos 3 e 4 e progresso dos demais
Co-Authored-By: Claude Sonnet 5.5 <noreply@anthropic.com>
Claude-Session: https://claude.ai/code/session_01MyK9xUsiCQsd2kvUck6yKF
</commit_message>
<xml_diff>
--- a/llm/slides/Cap08.pptx
+++ b/llm/slides/Cap08.pptx
@@ -8040,7 +8040,7 @@
                 </a:solidFill>
                 <a:latin typeface="Consolas"/>
               </a:rPr>
-              <a:t>Responda à pergunta usando APENAS os documentos abaixo. Cite o id do documento que sustenta a resposta. Se a resposta não estiver nos documentos, responda exatamente: não consta.</a:t>
+              <a:t>&lt;documento id="D12"&gt;</a:t>
             </a:r>
           </a:p>
           <a:p>
@@ -8052,7 +8052,7 @@
                 </a:solidFill>
                 <a:latin typeface="Consolas"/>
               </a:rPr>
-              <a:t/>
+              <a:t>O atraso na devolução gera multa de R$ 1,50 por dia e por exemplar.</a:t>
             </a:r>
           </a:p>
           <a:p>
@@ -8064,7 +8064,7 @@
                 </a:solidFill>
                 <a:latin typeface="Consolas"/>
               </a:rPr>
-              <a:t>&lt;documento id="D12"&gt;</a:t>
+              <a:t>...</a:t>
             </a:r>
           </a:p>
           <a:p>
@@ -8076,7 +8076,7 @@
                 </a:solidFill>
                 <a:latin typeface="Consolas"/>
               </a:rPr>
-              <a:t>O atraso na devolução gera multa de R$ 1,50 por dia e por exemplar. Quando a dívida passa de R$ 30,00, o empréstimo é suspenso até a quitação.</a:t>
+              <a:t>Pergunta: Qual a multa por atraso?</a:t>
             </a:r>
           </a:p>
           <a:p>
@@ -8088,7 +8088,7 @@
                 </a:solidFill>
                 <a:latin typeface="Consolas"/>
               </a:rPr>
-              <a:t>&lt;/documento&gt;</a:t>
+              <a:t>Resposta:</a:t>
             </a:r>
           </a:p>
         </p:txBody>

</xml_diff>